<commit_message>
Update shortcut reference slide
</commit_message>
<xml_diff>
--- a/VEXUM学園_ITリテラシー基礎講座_社内研修版.pptx
+++ b/VEXUM学園_ITリテラシー基礎講座_社内研修版.pptx
@@ -2,36 +2,36 @@
 <file path=ppt/presentation.xml><?xml version="1.0" encoding="utf-8"?>
 <p:presentation xmlns:p="http://schemas.openxmlformats.org/presentationml/2006/main">
   <p:sldMasterIdLst>
-    <p:sldMasterId xmlns:r="http://schemas.openxmlformats.org/officeDocument/2006/relationships" id="2147483648" r:id="R6e9bb953be8d417f"/>
+    <p:sldMasterId xmlns:r="http://schemas.openxmlformats.org/officeDocument/2006/relationships" id="2147483648" r:id="Ra8b94188442e4504"/>
   </p:sldMasterIdLst>
   <p:notesMasterIdLst>
-    <p:notesMasterId xmlns:r="http://schemas.openxmlformats.org/officeDocument/2006/relationships" r:id="R04b69b5e91d54338"/>
+    <p:notesMasterId xmlns:r="http://schemas.openxmlformats.org/officeDocument/2006/relationships" r:id="R30f7b19309df4c69"/>
   </p:notesMasterIdLst>
   <p:sldIdLst>
-    <p:sldId xmlns:r="http://schemas.openxmlformats.org/officeDocument/2006/relationships" id="256" r:id="R40976beb551e44b7"/>
-    <p:sldId xmlns:r="http://schemas.openxmlformats.org/officeDocument/2006/relationships" id="257" r:id="Rbc597db1c66a4e98"/>
-    <p:sldId xmlns:r="http://schemas.openxmlformats.org/officeDocument/2006/relationships" id="258" r:id="Rf8c93cc601ec46dc"/>
-    <p:sldId xmlns:r="http://schemas.openxmlformats.org/officeDocument/2006/relationships" id="259" r:id="R3ba3a110ac184348"/>
-    <p:sldId xmlns:r="http://schemas.openxmlformats.org/officeDocument/2006/relationships" id="260" r:id="R17aad0c2f9e745e2"/>
-    <p:sldId xmlns:r="http://schemas.openxmlformats.org/officeDocument/2006/relationships" id="261" r:id="R08728b71d2914965"/>
-    <p:sldId xmlns:r="http://schemas.openxmlformats.org/officeDocument/2006/relationships" id="262" r:id="R4c343f6aabac4f86"/>
-    <p:sldId xmlns:r="http://schemas.openxmlformats.org/officeDocument/2006/relationships" id="263" r:id="R48c5effc471240f7"/>
-    <p:sldId xmlns:r="http://schemas.openxmlformats.org/officeDocument/2006/relationships" id="264" r:id="Ra3e9f6a1161249ca"/>
-    <p:sldId xmlns:r="http://schemas.openxmlformats.org/officeDocument/2006/relationships" id="265" r:id="Rc26e8efad28040f0"/>
-    <p:sldId xmlns:r="http://schemas.openxmlformats.org/officeDocument/2006/relationships" id="266" r:id="Rc96d5d2e6f8c4f78"/>
-    <p:sldId xmlns:r="http://schemas.openxmlformats.org/officeDocument/2006/relationships" id="267" r:id="Rdf19a11f35ce49a6"/>
-    <p:sldId xmlns:r="http://schemas.openxmlformats.org/officeDocument/2006/relationships" id="268" r:id="R148739fbca1a4681"/>
-    <p:sldId xmlns:r="http://schemas.openxmlformats.org/officeDocument/2006/relationships" id="269" r:id="R11ae35d3584e4d82"/>
-    <p:sldId xmlns:r="http://schemas.openxmlformats.org/officeDocument/2006/relationships" id="270" r:id="Ra418aac96a0f4a81"/>
-    <p:sldId xmlns:r="http://schemas.openxmlformats.org/officeDocument/2006/relationships" id="271" r:id="Rf76e16bc1d1a4863"/>
-    <p:sldId xmlns:r="http://schemas.openxmlformats.org/officeDocument/2006/relationships" id="272" r:id="Ra5bb9ed5daab407b"/>
-    <p:sldId xmlns:r="http://schemas.openxmlformats.org/officeDocument/2006/relationships" id="273" r:id="Rd2962f655c374ff8"/>
-    <p:sldId xmlns:r="http://schemas.openxmlformats.org/officeDocument/2006/relationships" id="274" r:id="R577cdad927d04308"/>
-    <p:sldId xmlns:r="http://schemas.openxmlformats.org/officeDocument/2006/relationships" id="275" r:id="R6697072ebd814ed6"/>
-    <p:sldId xmlns:r="http://schemas.openxmlformats.org/officeDocument/2006/relationships" id="276" r:id="Ra15cef91b20e4261"/>
-    <p:sldId xmlns:r="http://schemas.openxmlformats.org/officeDocument/2006/relationships" id="277" r:id="R90e135538dc14405"/>
-    <p:sldId xmlns:r="http://schemas.openxmlformats.org/officeDocument/2006/relationships" id="278" r:id="R384d91a5bfda41b5"/>
-    <p:sldId xmlns:r="http://schemas.openxmlformats.org/officeDocument/2006/relationships" id="279" r:id="Rf47409f2b8224b51"/>
+    <p:sldId xmlns:r="http://schemas.openxmlformats.org/officeDocument/2006/relationships" id="256" r:id="Rac3f2ddc0ec04c20"/>
+    <p:sldId xmlns:r="http://schemas.openxmlformats.org/officeDocument/2006/relationships" id="257" r:id="R71f37a1e93c74039"/>
+    <p:sldId xmlns:r="http://schemas.openxmlformats.org/officeDocument/2006/relationships" id="258" r:id="Rea22227d6f404f23"/>
+    <p:sldId xmlns:r="http://schemas.openxmlformats.org/officeDocument/2006/relationships" id="259" r:id="Rcc5399de88f14310"/>
+    <p:sldId xmlns:r="http://schemas.openxmlformats.org/officeDocument/2006/relationships" id="260" r:id="Rdfdbeefe6ca9454a"/>
+    <p:sldId xmlns:r="http://schemas.openxmlformats.org/officeDocument/2006/relationships" id="261" r:id="Rd2e426da3cd04966"/>
+    <p:sldId xmlns:r="http://schemas.openxmlformats.org/officeDocument/2006/relationships" id="262" r:id="R92468fdd0d414709"/>
+    <p:sldId xmlns:r="http://schemas.openxmlformats.org/officeDocument/2006/relationships" id="263" r:id="Rc9c8acffcaf04051"/>
+    <p:sldId xmlns:r="http://schemas.openxmlformats.org/officeDocument/2006/relationships" id="264" r:id="R3f637ea2e4fa42aa"/>
+    <p:sldId xmlns:r="http://schemas.openxmlformats.org/officeDocument/2006/relationships" id="265" r:id="R262d2c68c38742a8"/>
+    <p:sldId xmlns:r="http://schemas.openxmlformats.org/officeDocument/2006/relationships" id="266" r:id="Rbc669397530340e7"/>
+    <p:sldId xmlns:r="http://schemas.openxmlformats.org/officeDocument/2006/relationships" id="267" r:id="R118c029447664fa4"/>
+    <p:sldId xmlns:r="http://schemas.openxmlformats.org/officeDocument/2006/relationships" id="268" r:id="R75346c2906b54d65"/>
+    <p:sldId xmlns:r="http://schemas.openxmlformats.org/officeDocument/2006/relationships" id="269" r:id="Rb54dc064dde64d76"/>
+    <p:sldId xmlns:r="http://schemas.openxmlformats.org/officeDocument/2006/relationships" id="270" r:id="R53304c8e93574971"/>
+    <p:sldId xmlns:r="http://schemas.openxmlformats.org/officeDocument/2006/relationships" id="271" r:id="R119a0e4f27d74c13"/>
+    <p:sldId xmlns:r="http://schemas.openxmlformats.org/officeDocument/2006/relationships" id="272" r:id="R143f6256d0b84d87"/>
+    <p:sldId xmlns:r="http://schemas.openxmlformats.org/officeDocument/2006/relationships" id="273" r:id="R0862556cac3b4c35"/>
+    <p:sldId xmlns:r="http://schemas.openxmlformats.org/officeDocument/2006/relationships" id="274" r:id="R37de1e424ca04da1"/>
+    <p:sldId xmlns:r="http://schemas.openxmlformats.org/officeDocument/2006/relationships" id="275" r:id="Re97080f8398e4924"/>
+    <p:sldId xmlns:r="http://schemas.openxmlformats.org/officeDocument/2006/relationships" id="276" r:id="R48e4e82a37b342ff"/>
+    <p:sldId xmlns:r="http://schemas.openxmlformats.org/officeDocument/2006/relationships" id="277" r:id="R75dac566f3b247ea"/>
+    <p:sldId xmlns:r="http://schemas.openxmlformats.org/officeDocument/2006/relationships" id="278" r:id="Rc406104618084e67"/>
+    <p:sldId xmlns:r="http://schemas.openxmlformats.org/officeDocument/2006/relationships" id="279" r:id="R07c8ac3f27154687"/>
   </p:sldIdLst>
   <p:sldSz cx="12192000" cy="6858000"/>
   <p:notesSz cx="6858000" cy="9144000"/>
@@ -1995,7 +1995,7 @@
           <a:lstStyle xmlns:a="http://schemas.openxmlformats.org/drawingml/2006/main"/>
           <a:p xmlns:a="http://schemas.openxmlformats.org/drawingml/2006/main">
             <a:r>
-              <a:t>最初から8個以上を暗記させない。C/V/Z/Fの4つを講座中に何度も使って定着させる。</a:t>
+              <a:t>C/V/Z/A/S/Xの6つを講座中に繰り返し使用して定着させる。切り取りは、元の場所から内容が移動する点を説明する。</a:t>
             </a:r>
           </a:p>
         </p:txBody>
@@ -2203,7 +2203,7 @@
   </p:cSld>
   <p:clrMap bg1="lt1" tx1="dk1" bg2="lt2" tx2="dk2" accent1="accent1" accent2="accent2" accent3="accent3" accent4="accent4" accent5="accent5" accent6="accent6" hlink="hlink" folHlink="folHlink"/>
   <p:sldLayoutIdLst>
-    <p:sldLayoutId xmlns:r="http://schemas.openxmlformats.org/officeDocument/2006/relationships" id="2147483649" r:id="Rd5262512c71b40f0"/>
+    <p:sldLayoutId xmlns:r="http://schemas.openxmlformats.org/officeDocument/2006/relationships" id="2147483649" r:id="R772c5065fd3a4430"/>
   </p:sldLayoutIdLst>
   <p:txStyles>
     <p:titleStyle>
@@ -26045,7 +26045,7 @@
         <p:spPr>
           <a:xfrm xmlns:a="http://schemas.openxmlformats.org/drawingml/2006/main">
             <a:off x="533400" y="1809750"/>
-            <a:ext cx="5181600" cy="1466850"/>
+            <a:ext cx="3371850" cy="1466850"/>
           </a:xfrm>
           <a:prstGeom xmlns:a="http://schemas.openxmlformats.org/drawingml/2006/main" prst="roundRect">
             <a:avLst>
@@ -26080,7 +26080,7 @@
         <p:spPr>
           <a:xfrm xmlns:a="http://schemas.openxmlformats.org/drawingml/2006/main">
             <a:off x="762000" y="2019300"/>
-            <a:ext cx="1524000" cy="304800"/>
+            <a:ext cx="1104900" cy="304800"/>
           </a:xfrm>
           <a:prstGeom xmlns:a="http://schemas.openxmlformats.org/drawingml/2006/main" prst="rect">
             <a:avLst/>
@@ -26138,8 +26138,8 @@
         </p:nvSpPr>
         <p:spPr>
           <a:xfrm xmlns:a="http://schemas.openxmlformats.org/drawingml/2006/main">
-            <a:off x="2381250" y="2000250"/>
-            <a:ext cx="2952750" cy="323850"/>
+            <a:off x="1962150" y="2000250"/>
+            <a:ext cx="1714500" cy="323850"/>
           </a:xfrm>
           <a:prstGeom xmlns:a="http://schemas.openxmlformats.org/drawingml/2006/main" prst="roundRect">
             <a:avLst>
@@ -26173,8 +26173,8 @@
         </p:nvSpPr>
         <p:spPr>
           <a:xfrm xmlns:a="http://schemas.openxmlformats.org/drawingml/2006/main">
-            <a:off x="2476500" y="2047875"/>
-            <a:ext cx="2762250" cy="228600"/>
+            <a:off x="2057400" y="2047875"/>
+            <a:ext cx="1524000" cy="228600"/>
           </a:xfrm>
           <a:prstGeom xmlns:a="http://schemas.openxmlformats.org/drawingml/2006/main" prst="rect">
             <a:avLst/>
@@ -26233,7 +26233,7 @@
         <p:spPr>
           <a:xfrm xmlns:a="http://schemas.openxmlformats.org/drawingml/2006/main">
             <a:off x="762000" y="2590800"/>
-            <a:ext cx="4686300" cy="323850"/>
+            <a:ext cx="2914650" cy="381000"/>
           </a:xfrm>
           <a:prstGeom xmlns:a="http://schemas.openxmlformats.org/drawingml/2006/main" prst="rect">
             <a:avLst/>
@@ -26291,8 +26291,8 @@
         </p:nvSpPr>
         <p:spPr>
           <a:xfrm xmlns:a="http://schemas.openxmlformats.org/drawingml/2006/main">
-            <a:off x="6096000" y="1809750"/>
-            <a:ext cx="5181600" cy="1466850"/>
+            <a:off x="4410075" y="1809750"/>
+            <a:ext cx="3371850" cy="1466850"/>
           </a:xfrm>
           <a:prstGeom xmlns:a="http://schemas.openxmlformats.org/drawingml/2006/main" prst="roundRect">
             <a:avLst>
@@ -26326,8 +26326,8 @@
         </p:nvSpPr>
         <p:spPr>
           <a:xfrm xmlns:a="http://schemas.openxmlformats.org/drawingml/2006/main">
-            <a:off x="6324600" y="2019300"/>
-            <a:ext cx="1524000" cy="304800"/>
+            <a:off x="4638675" y="2019300"/>
+            <a:ext cx="1104900" cy="304800"/>
           </a:xfrm>
           <a:prstGeom xmlns:a="http://schemas.openxmlformats.org/drawingml/2006/main" prst="rect">
             <a:avLst/>
@@ -26385,8 +26385,8 @@
         </p:nvSpPr>
         <p:spPr>
           <a:xfrm xmlns:a="http://schemas.openxmlformats.org/drawingml/2006/main">
-            <a:off x="7943850" y="2000250"/>
-            <a:ext cx="2952750" cy="323850"/>
+            <a:off x="5838825" y="2000250"/>
+            <a:ext cx="1714500" cy="323850"/>
           </a:xfrm>
           <a:prstGeom xmlns:a="http://schemas.openxmlformats.org/drawingml/2006/main" prst="roundRect">
             <a:avLst>
@@ -26420,8 +26420,8 @@
         </p:nvSpPr>
         <p:spPr>
           <a:xfrm xmlns:a="http://schemas.openxmlformats.org/drawingml/2006/main">
-            <a:off x="8039100" y="2047875"/>
-            <a:ext cx="2762250" cy="228600"/>
+            <a:off x="5934075" y="2047875"/>
+            <a:ext cx="1524000" cy="228600"/>
           </a:xfrm>
           <a:prstGeom xmlns:a="http://schemas.openxmlformats.org/drawingml/2006/main" prst="rect">
             <a:avLst/>
@@ -26479,8 +26479,8 @@
         </p:nvSpPr>
         <p:spPr>
           <a:xfrm xmlns:a="http://schemas.openxmlformats.org/drawingml/2006/main">
-            <a:off x="6324600" y="2590800"/>
-            <a:ext cx="4686300" cy="323850"/>
+            <a:off x="4638675" y="2590800"/>
+            <a:ext cx="2914650" cy="381000"/>
           </a:xfrm>
           <a:prstGeom xmlns:a="http://schemas.openxmlformats.org/drawingml/2006/main" prst="rect">
             <a:avLst/>
@@ -26517,7 +26517,7 @@
                 <a:ea typeface="Helvetica Neue"/>
                 <a:cs typeface="Helvetica Neue"/>
               </a:rPr>
-              <a:t>コピーしたものを置く</a:t>
+              <a:t>コピーした内容を置く</a:t>
             </a:r>
           </a:p>
         </p:txBody>
@@ -26538,8 +26538,8 @@
         </p:nvSpPr>
         <p:spPr>
           <a:xfrm xmlns:a="http://schemas.openxmlformats.org/drawingml/2006/main">
-            <a:off x="533400" y="3619500"/>
-            <a:ext cx="5181600" cy="1466850"/>
+            <a:off x="8286750" y="1809750"/>
+            <a:ext cx="3371850" cy="1466850"/>
           </a:xfrm>
           <a:prstGeom xmlns:a="http://schemas.openxmlformats.org/drawingml/2006/main" prst="roundRect">
             <a:avLst>
@@ -26573,8 +26573,8 @@
         </p:nvSpPr>
         <p:spPr>
           <a:xfrm xmlns:a="http://schemas.openxmlformats.org/drawingml/2006/main">
-            <a:off x="762000" y="3829050"/>
-            <a:ext cx="1524000" cy="304800"/>
+            <a:off x="8515350" y="2019300"/>
+            <a:ext cx="1104900" cy="304800"/>
           </a:xfrm>
           <a:prstGeom xmlns:a="http://schemas.openxmlformats.org/drawingml/2006/main" prst="rect">
             <a:avLst/>
@@ -26632,8 +26632,8 @@
         </p:nvSpPr>
         <p:spPr>
           <a:xfrm xmlns:a="http://schemas.openxmlformats.org/drawingml/2006/main">
-            <a:off x="2381250" y="3810000"/>
-            <a:ext cx="2952750" cy="323850"/>
+            <a:off x="9715500" y="2000250"/>
+            <a:ext cx="1714500" cy="323850"/>
           </a:xfrm>
           <a:prstGeom xmlns:a="http://schemas.openxmlformats.org/drawingml/2006/main" prst="roundRect">
             <a:avLst>
@@ -26667,8 +26667,8 @@
         </p:nvSpPr>
         <p:spPr>
           <a:xfrm xmlns:a="http://schemas.openxmlformats.org/drawingml/2006/main">
-            <a:off x="2476500" y="3857625"/>
-            <a:ext cx="2762250" cy="228600"/>
+            <a:off x="9810750" y="2047875"/>
+            <a:ext cx="1524000" cy="228600"/>
           </a:xfrm>
           <a:prstGeom xmlns:a="http://schemas.openxmlformats.org/drawingml/2006/main" prst="rect">
             <a:avLst/>
@@ -26726,8 +26726,8 @@
         </p:nvSpPr>
         <p:spPr>
           <a:xfrm xmlns:a="http://schemas.openxmlformats.org/drawingml/2006/main">
-            <a:off x="762000" y="4400550"/>
-            <a:ext cx="4686300" cy="323850"/>
+            <a:off x="8515350" y="2590800"/>
+            <a:ext cx="2914650" cy="381000"/>
           </a:xfrm>
           <a:prstGeom xmlns:a="http://schemas.openxmlformats.org/drawingml/2006/main" prst="rect">
             <a:avLst/>
@@ -26785,8 +26785,8 @@
         </p:nvSpPr>
         <p:spPr>
           <a:xfrm xmlns:a="http://schemas.openxmlformats.org/drawingml/2006/main">
-            <a:off x="6096000" y="3619500"/>
-            <a:ext cx="5181600" cy="1466850"/>
+            <a:off x="533400" y="3619500"/>
+            <a:ext cx="3371850" cy="1466850"/>
           </a:xfrm>
           <a:prstGeom xmlns:a="http://schemas.openxmlformats.org/drawingml/2006/main" prst="roundRect">
             <a:avLst>
@@ -26820,8 +26820,8 @@
         </p:nvSpPr>
         <p:spPr>
           <a:xfrm xmlns:a="http://schemas.openxmlformats.org/drawingml/2006/main">
-            <a:off x="6324600" y="3829050"/>
-            <a:ext cx="1524000" cy="304800"/>
+            <a:off x="762000" y="3829050"/>
+            <a:ext cx="1104900" cy="304800"/>
           </a:xfrm>
           <a:prstGeom xmlns:a="http://schemas.openxmlformats.org/drawingml/2006/main" prst="rect">
             <a:avLst/>
@@ -26858,7 +26858,7 @@
                 <a:ea typeface="Helvetica Neue"/>
                 <a:cs typeface="Helvetica Neue"/>
               </a:rPr>
-              <a:t>検索</a:t>
+              <a:t>全選択</a:t>
             </a:r>
           </a:p>
         </p:txBody>
@@ -26879,8 +26879,8 @@
         </p:nvSpPr>
         <p:spPr>
           <a:xfrm xmlns:a="http://schemas.openxmlformats.org/drawingml/2006/main">
-            <a:off x="7943850" y="3810000"/>
-            <a:ext cx="2952750" cy="323850"/>
+            <a:off x="1962150" y="3810000"/>
+            <a:ext cx="1714500" cy="323850"/>
           </a:xfrm>
           <a:prstGeom xmlns:a="http://schemas.openxmlformats.org/drawingml/2006/main" prst="roundRect">
             <a:avLst>
@@ -26914,8 +26914,8 @@
         </p:nvSpPr>
         <p:spPr>
           <a:xfrm xmlns:a="http://schemas.openxmlformats.org/drawingml/2006/main">
-            <a:off x="8039100" y="3857625"/>
-            <a:ext cx="2762250" cy="228600"/>
+            <a:off x="2057400" y="3857625"/>
+            <a:ext cx="1524000" cy="228600"/>
           </a:xfrm>
           <a:prstGeom xmlns:a="http://schemas.openxmlformats.org/drawingml/2006/main" prst="rect">
             <a:avLst/>
@@ -26952,7 +26952,7 @@
                 <a:ea typeface="Helvetica Neue"/>
                 <a:cs typeface="Helvetica Neue"/>
               </a:rPr>
-              <a:t>Ctrl / ⌘ + F</a:t>
+              <a:t>Ctrl / ⌘ + A</a:t>
             </a:r>
           </a:p>
         </p:txBody>
@@ -26973,8 +26973,8 @@
         </p:nvSpPr>
         <p:spPr>
           <a:xfrm xmlns:a="http://schemas.openxmlformats.org/drawingml/2006/main">
-            <a:off x="6324600" y="4400550"/>
-            <a:ext cx="4686300" cy="323850"/>
+            <a:off x="762000" y="4400550"/>
+            <a:ext cx="2914650" cy="381000"/>
           </a:xfrm>
           <a:prstGeom xmlns:a="http://schemas.openxmlformats.org/drawingml/2006/main" prst="rect">
             <a:avLst/>
@@ -27011,7 +27011,7 @@
                 <a:ea typeface="Helvetica Neue"/>
                 <a:cs typeface="Helvetica Neue"/>
               </a:rPr>
-              <a:t>ページや文書の中を探す</a:t>
+              <a:t>すべての文字や項目を選ぶ</a:t>
             </a:r>
           </a:p>
         </p:txBody>
@@ -27071,6 +27071,494 @@
                 <a:cs typeface="Helvetica Neue"/>
               </a:rPr>
               <a:t>Windowsは Ctrl、Macは ⌘（command）を使います。</a:t>
+            </a:r>
+          </a:p>
+        </p:txBody>
+      </p:sp>
+      <p:sp>
+        <p:nvSpPr>
+          <p:cNvPr id="29" name="shortcut-save-background">
+            <a:extLst xmlns:a="http://schemas.openxmlformats.org/drawingml/2006/main">
+              <a:ext uri="{FF2B5EF4-FFF2-40B4-BE49-F238E27FC236}">
+                <a16:creationId xmlns:a16="http://schemas.microsoft.com/office/drawing/2014/main" id="{CF230B4D-5B87-43D0-860B-8A92624F7C61}"/>
+              </a:ext>
+            </a:extLst>
+          </p:cNvPr>
+          <p:cNvSpPr>
+            <a:spLocks xmlns:a="http://schemas.openxmlformats.org/drawingml/2006/main" noGrp="1"/>
+          </p:cNvSpPr>
+          <p:nvPr/>
+        </p:nvSpPr>
+        <p:spPr>
+          <a:xfrm xmlns:a="http://schemas.openxmlformats.org/drawingml/2006/main">
+            <a:off x="4410075" y="3619500"/>
+            <a:ext cx="3371850" cy="1466850"/>
+          </a:xfrm>
+          <a:prstGeom xmlns:a="http://schemas.openxmlformats.org/drawingml/2006/main" prst="roundRect">
+            <a:avLst>
+              <a:gd name="adj" fmla="val 5195"/>
+            </a:avLst>
+          </a:prstGeom>
+          <a:solidFill xmlns:a="http://schemas.openxmlformats.org/drawingml/2006/main">
+            <a:srgbClr val="F6F8FB"/>
+          </a:solidFill>
+          <a:ln xmlns:a="http://schemas.openxmlformats.org/drawingml/2006/main" w="9525">
+            <a:solidFill>
+              <a:srgbClr val="DDE3EC"/>
+            </a:solidFill>
+            <a:prstDash val="solid"/>
+          </a:ln>
+        </p:spPr>
+      </p:sp>
+      <p:sp>
+        <p:nvSpPr>
+          <p:cNvPr id="30" name="shortcut-save-title">
+            <a:extLst xmlns:a="http://schemas.openxmlformats.org/drawingml/2006/main">
+              <a:ext uri="{FF2B5EF4-FFF2-40B4-BE49-F238E27FC236}">
+                <a16:creationId xmlns:a16="http://schemas.microsoft.com/office/drawing/2014/main" id="{840BA0C3-215E-4E39-9F13-BF49212A2736}"/>
+              </a:ext>
+            </a:extLst>
+          </p:cNvPr>
+          <p:cNvSpPr>
+            <a:spLocks xmlns:a="http://schemas.openxmlformats.org/drawingml/2006/main" noGrp="1"/>
+          </p:cNvSpPr>
+          <p:nvPr/>
+        </p:nvSpPr>
+        <p:spPr>
+          <a:xfrm xmlns:a="http://schemas.openxmlformats.org/drawingml/2006/main">
+            <a:off x="4638675" y="3829050"/>
+            <a:ext cx="1104900" cy="304800"/>
+          </a:xfrm>
+          <a:prstGeom xmlns:a="http://schemas.openxmlformats.org/drawingml/2006/main" prst="rect">
+            <a:avLst/>
+          </a:prstGeom>
+          <a:noFill xmlns:a="http://schemas.openxmlformats.org/drawingml/2006/main"/>
+          <a:ln xmlns:a="http://schemas.openxmlformats.org/drawingml/2006/main" w="0">
+            <a:noFill/>
+            <a:prstDash val="solid"/>
+          </a:ln>
+        </p:spPr>
+        <p:txBody>
+          <a:bodyPr xmlns:a="http://schemas.openxmlformats.org/drawingml/2006/main" anchor="t">
+            <a:normAutofit fontScale="77778"/>
+          </a:bodyPr>
+          <a:lstStyle xmlns:a="http://schemas.openxmlformats.org/drawingml/2006/main"/>
+          <a:p xmlns:a="http://schemas.openxmlformats.org/drawingml/2006/main">
+            <a:pPr algn="l">
+              <a:defRPr sz="1800" b="1">
+                <a:solidFill>
+                  <a:srgbClr val="142033"/>
+                </a:solidFill>
+                <a:latin typeface="Helvetica Neue"/>
+                <a:ea typeface="Helvetica Neue"/>
+                <a:cs typeface="Helvetica Neue"/>
+              </a:defRPr>
+            </a:pPr>
+            <a:r>
+              <a:rPr sz="1800" b="1">
+                <a:solidFill>
+                  <a:srgbClr val="142033"/>
+                </a:solidFill>
+                <a:latin typeface="Helvetica Neue"/>
+                <a:ea typeface="Helvetica Neue"/>
+                <a:cs typeface="Helvetica Neue"/>
+              </a:rPr>
+              <a:t>保存</a:t>
+            </a:r>
+          </a:p>
+        </p:txBody>
+      </p:sp>
+      <p:sp>
+        <p:nvSpPr>
+          <p:cNvPr id="31" name="shortcut-save-key-background">
+            <a:extLst xmlns:a="http://schemas.openxmlformats.org/drawingml/2006/main">
+              <a:ext uri="{FF2B5EF4-FFF2-40B4-BE49-F238E27FC236}">
+                <a16:creationId xmlns:a16="http://schemas.microsoft.com/office/drawing/2014/main" id="{1C67FFDE-8C83-4056-AC44-3782E0025219}"/>
+              </a:ext>
+            </a:extLst>
+          </p:cNvPr>
+          <p:cNvSpPr>
+            <a:spLocks xmlns:a="http://schemas.openxmlformats.org/drawingml/2006/main" noGrp="1"/>
+          </p:cNvSpPr>
+          <p:nvPr/>
+        </p:nvSpPr>
+        <p:spPr>
+          <a:xfrm xmlns:a="http://schemas.openxmlformats.org/drawingml/2006/main">
+            <a:off x="5838825" y="3810000"/>
+            <a:ext cx="1714500" cy="323850"/>
+          </a:xfrm>
+          <a:prstGeom xmlns:a="http://schemas.openxmlformats.org/drawingml/2006/main" prst="roundRect">
+            <a:avLst>
+              <a:gd name="adj" fmla="val 23529"/>
+            </a:avLst>
+          </a:prstGeom>
+          <a:solidFill xmlns:a="http://schemas.openxmlformats.org/drawingml/2006/main">
+            <a:srgbClr val="FFFFFF"/>
+          </a:solidFill>
+          <a:ln xmlns:a="http://schemas.openxmlformats.org/drawingml/2006/main" w="9525">
+            <a:solidFill>
+              <a:srgbClr val="FFFFFF"/>
+            </a:solidFill>
+            <a:prstDash val="solid"/>
+          </a:ln>
+        </p:spPr>
+      </p:sp>
+      <p:sp>
+        <p:nvSpPr>
+          <p:cNvPr id="32" name="shortcut-save-key">
+            <a:extLst xmlns:a="http://schemas.openxmlformats.org/drawingml/2006/main">
+              <a:ext uri="{FF2B5EF4-FFF2-40B4-BE49-F238E27FC236}">
+                <a16:creationId xmlns:a16="http://schemas.microsoft.com/office/drawing/2014/main" id="{CA9D3058-181A-47B1-BFEB-850EEA3617A7}"/>
+              </a:ext>
+            </a:extLst>
+          </p:cNvPr>
+          <p:cNvSpPr>
+            <a:spLocks xmlns:a="http://schemas.openxmlformats.org/drawingml/2006/main" noGrp="1"/>
+          </p:cNvSpPr>
+          <p:nvPr/>
+        </p:nvSpPr>
+        <p:spPr>
+          <a:xfrm xmlns:a="http://schemas.openxmlformats.org/drawingml/2006/main">
+            <a:off x="5934075" y="3857625"/>
+            <a:ext cx="1524000" cy="228600"/>
+          </a:xfrm>
+          <a:prstGeom xmlns:a="http://schemas.openxmlformats.org/drawingml/2006/main" prst="rect">
+            <a:avLst/>
+          </a:prstGeom>
+          <a:noFill xmlns:a="http://schemas.openxmlformats.org/drawingml/2006/main"/>
+          <a:ln xmlns:a="http://schemas.openxmlformats.org/drawingml/2006/main" w="0">
+            <a:noFill/>
+            <a:prstDash val="solid"/>
+          </a:ln>
+        </p:spPr>
+        <p:txBody>
+          <a:bodyPr xmlns:a="http://schemas.openxmlformats.org/drawingml/2006/main" anchor="ctr">
+            <a:normAutofit fontScale="85714"/>
+          </a:bodyPr>
+          <a:lstStyle xmlns:a="http://schemas.openxmlformats.org/drawingml/2006/main"/>
+          <a:p xmlns:a="http://schemas.openxmlformats.org/drawingml/2006/main">
+            <a:pPr algn="ctr">
+              <a:defRPr sz="1050" b="1">
+                <a:solidFill>
+                  <a:srgbClr val="246BFD"/>
+                </a:solidFill>
+                <a:latin typeface="Helvetica Neue"/>
+                <a:ea typeface="Helvetica Neue"/>
+                <a:cs typeface="Helvetica Neue"/>
+              </a:defRPr>
+            </a:pPr>
+            <a:r>
+              <a:rPr sz="1050" b="1">
+                <a:solidFill>
+                  <a:srgbClr val="246BFD"/>
+                </a:solidFill>
+                <a:latin typeface="Helvetica Neue"/>
+                <a:ea typeface="Helvetica Neue"/>
+                <a:cs typeface="Helvetica Neue"/>
+              </a:rPr>
+              <a:t>Ctrl / ⌘ + S</a:t>
+            </a:r>
+          </a:p>
+        </p:txBody>
+      </p:sp>
+      <p:sp>
+        <p:nvSpPr>
+          <p:cNvPr id="33" name="shortcut-save-description">
+            <a:extLst xmlns:a="http://schemas.openxmlformats.org/drawingml/2006/main">
+              <a:ext uri="{FF2B5EF4-FFF2-40B4-BE49-F238E27FC236}">
+                <a16:creationId xmlns:a16="http://schemas.microsoft.com/office/drawing/2014/main" id="{6A7A05D8-25C4-4412-845F-C84BF69285C3}"/>
+              </a:ext>
+            </a:extLst>
+          </p:cNvPr>
+          <p:cNvSpPr>
+            <a:spLocks xmlns:a="http://schemas.openxmlformats.org/drawingml/2006/main" noGrp="1"/>
+          </p:cNvSpPr>
+          <p:nvPr/>
+        </p:nvSpPr>
+        <p:spPr>
+          <a:xfrm xmlns:a="http://schemas.openxmlformats.org/drawingml/2006/main">
+            <a:off x="4638675" y="4400550"/>
+            <a:ext cx="2914650" cy="381000"/>
+          </a:xfrm>
+          <a:prstGeom xmlns:a="http://schemas.openxmlformats.org/drawingml/2006/main" prst="rect">
+            <a:avLst/>
+          </a:prstGeom>
+          <a:noFill xmlns:a="http://schemas.openxmlformats.org/drawingml/2006/main"/>
+          <a:ln xmlns:a="http://schemas.openxmlformats.org/drawingml/2006/main" w="0">
+            <a:noFill/>
+            <a:prstDash val="solid"/>
+          </a:ln>
+        </p:spPr>
+        <p:txBody>
+          <a:bodyPr xmlns:a="http://schemas.openxmlformats.org/drawingml/2006/main" anchor="t">
+            <a:normAutofit fontScale="100000"/>
+          </a:bodyPr>
+          <a:lstStyle xmlns:a="http://schemas.openxmlformats.org/drawingml/2006/main"/>
+          <a:p xmlns:a="http://schemas.openxmlformats.org/drawingml/2006/main">
+            <a:pPr algn="l">
+              <a:defRPr sz="1575">
+                <a:solidFill>
+                  <a:srgbClr val="5B667A"/>
+                </a:solidFill>
+                <a:latin typeface="Helvetica Neue"/>
+                <a:ea typeface="Helvetica Neue"/>
+                <a:cs typeface="Helvetica Neue"/>
+              </a:defRPr>
+            </a:pPr>
+            <a:r>
+              <a:rPr sz="1575">
+                <a:solidFill>
+                  <a:srgbClr val="5B667A"/>
+                </a:solidFill>
+                <a:latin typeface="Helvetica Neue"/>
+                <a:ea typeface="Helvetica Neue"/>
+                <a:cs typeface="Helvetica Neue"/>
+              </a:rPr>
+              <a:t>編集内容を保存する</a:t>
+            </a:r>
+          </a:p>
+        </p:txBody>
+      </p:sp>
+      <p:sp>
+        <p:nvSpPr>
+          <p:cNvPr id="34" name="shortcut-cut-background">
+            <a:extLst xmlns:a="http://schemas.openxmlformats.org/drawingml/2006/main">
+              <a:ext uri="{FF2B5EF4-FFF2-40B4-BE49-F238E27FC236}">
+                <a16:creationId xmlns:a16="http://schemas.microsoft.com/office/drawing/2014/main" id="{29140AC1-CE65-48DB-896C-E9D2CB44E09B}"/>
+              </a:ext>
+            </a:extLst>
+          </p:cNvPr>
+          <p:cNvSpPr>
+            <a:spLocks xmlns:a="http://schemas.openxmlformats.org/drawingml/2006/main" noGrp="1"/>
+          </p:cNvSpPr>
+          <p:nvPr/>
+        </p:nvSpPr>
+        <p:spPr>
+          <a:xfrm xmlns:a="http://schemas.openxmlformats.org/drawingml/2006/main">
+            <a:off x="8286750" y="3619500"/>
+            <a:ext cx="3371850" cy="1466850"/>
+          </a:xfrm>
+          <a:prstGeom xmlns:a="http://schemas.openxmlformats.org/drawingml/2006/main" prst="roundRect">
+            <a:avLst>
+              <a:gd name="adj" fmla="val 5195"/>
+            </a:avLst>
+          </a:prstGeom>
+          <a:solidFill xmlns:a="http://schemas.openxmlformats.org/drawingml/2006/main">
+            <a:srgbClr val="F6F8FB"/>
+          </a:solidFill>
+          <a:ln xmlns:a="http://schemas.openxmlformats.org/drawingml/2006/main" w="9525">
+            <a:solidFill>
+              <a:srgbClr val="DDE3EC"/>
+            </a:solidFill>
+            <a:prstDash val="solid"/>
+          </a:ln>
+        </p:spPr>
+      </p:sp>
+      <p:sp>
+        <p:nvSpPr>
+          <p:cNvPr id="35" name="shortcut-cut-title">
+            <a:extLst xmlns:a="http://schemas.openxmlformats.org/drawingml/2006/main">
+              <a:ext uri="{FF2B5EF4-FFF2-40B4-BE49-F238E27FC236}">
+                <a16:creationId xmlns:a16="http://schemas.microsoft.com/office/drawing/2014/main" id="{1C1380EE-DBB2-418D-AF72-B0E99ACD3FC9}"/>
+              </a:ext>
+            </a:extLst>
+          </p:cNvPr>
+          <p:cNvSpPr>
+            <a:spLocks xmlns:a="http://schemas.openxmlformats.org/drawingml/2006/main" noGrp="1"/>
+          </p:cNvSpPr>
+          <p:nvPr/>
+        </p:nvSpPr>
+        <p:spPr>
+          <a:xfrm xmlns:a="http://schemas.openxmlformats.org/drawingml/2006/main">
+            <a:off x="8515350" y="3829050"/>
+            <a:ext cx="1104900" cy="304800"/>
+          </a:xfrm>
+          <a:prstGeom xmlns:a="http://schemas.openxmlformats.org/drawingml/2006/main" prst="rect">
+            <a:avLst/>
+          </a:prstGeom>
+          <a:noFill xmlns:a="http://schemas.openxmlformats.org/drawingml/2006/main"/>
+          <a:ln xmlns:a="http://schemas.openxmlformats.org/drawingml/2006/main" w="0">
+            <a:noFill/>
+            <a:prstDash val="solid"/>
+          </a:ln>
+        </p:spPr>
+        <p:txBody>
+          <a:bodyPr xmlns:a="http://schemas.openxmlformats.org/drawingml/2006/main" anchor="t">
+            <a:normAutofit fontScale="77778"/>
+          </a:bodyPr>
+          <a:lstStyle xmlns:a="http://schemas.openxmlformats.org/drawingml/2006/main"/>
+          <a:p xmlns:a="http://schemas.openxmlformats.org/drawingml/2006/main">
+            <a:pPr algn="l">
+              <a:defRPr sz="1800" b="1">
+                <a:solidFill>
+                  <a:srgbClr val="142033"/>
+                </a:solidFill>
+                <a:latin typeface="Helvetica Neue"/>
+                <a:ea typeface="Helvetica Neue"/>
+                <a:cs typeface="Helvetica Neue"/>
+              </a:defRPr>
+            </a:pPr>
+            <a:r>
+              <a:rPr sz="1800" b="1">
+                <a:solidFill>
+                  <a:srgbClr val="142033"/>
+                </a:solidFill>
+                <a:latin typeface="Helvetica Neue"/>
+                <a:ea typeface="Helvetica Neue"/>
+                <a:cs typeface="Helvetica Neue"/>
+              </a:rPr>
+              <a:t>切り取り</a:t>
+            </a:r>
+          </a:p>
+        </p:txBody>
+      </p:sp>
+      <p:sp>
+        <p:nvSpPr>
+          <p:cNvPr id="36" name="shortcut-cut-key-background">
+            <a:extLst xmlns:a="http://schemas.openxmlformats.org/drawingml/2006/main">
+              <a:ext uri="{FF2B5EF4-FFF2-40B4-BE49-F238E27FC236}">
+                <a16:creationId xmlns:a16="http://schemas.microsoft.com/office/drawing/2014/main" id="{65D319BD-BB6C-49E0-BEA3-7D42E5CFF2DE}"/>
+              </a:ext>
+            </a:extLst>
+          </p:cNvPr>
+          <p:cNvSpPr>
+            <a:spLocks xmlns:a="http://schemas.openxmlformats.org/drawingml/2006/main" noGrp="1"/>
+          </p:cNvSpPr>
+          <p:nvPr/>
+        </p:nvSpPr>
+        <p:spPr>
+          <a:xfrm xmlns:a="http://schemas.openxmlformats.org/drawingml/2006/main">
+            <a:off x="9715500" y="3810000"/>
+            <a:ext cx="1714500" cy="323850"/>
+          </a:xfrm>
+          <a:prstGeom xmlns:a="http://schemas.openxmlformats.org/drawingml/2006/main" prst="roundRect">
+            <a:avLst>
+              <a:gd name="adj" fmla="val 23529"/>
+            </a:avLst>
+          </a:prstGeom>
+          <a:solidFill xmlns:a="http://schemas.openxmlformats.org/drawingml/2006/main">
+            <a:srgbClr val="FFFFFF"/>
+          </a:solidFill>
+          <a:ln xmlns:a="http://schemas.openxmlformats.org/drawingml/2006/main" w="9525">
+            <a:solidFill>
+              <a:srgbClr val="FFFFFF"/>
+            </a:solidFill>
+            <a:prstDash val="solid"/>
+          </a:ln>
+        </p:spPr>
+      </p:sp>
+      <p:sp>
+        <p:nvSpPr>
+          <p:cNvPr id="37" name="shortcut-cut-key">
+            <a:extLst xmlns:a="http://schemas.openxmlformats.org/drawingml/2006/main">
+              <a:ext uri="{FF2B5EF4-FFF2-40B4-BE49-F238E27FC236}">
+                <a16:creationId xmlns:a16="http://schemas.microsoft.com/office/drawing/2014/main" id="{53882DEB-6012-4679-A849-58A915933682}"/>
+              </a:ext>
+            </a:extLst>
+          </p:cNvPr>
+          <p:cNvSpPr>
+            <a:spLocks xmlns:a="http://schemas.openxmlformats.org/drawingml/2006/main" noGrp="1"/>
+          </p:cNvSpPr>
+          <p:nvPr/>
+        </p:nvSpPr>
+        <p:spPr>
+          <a:xfrm xmlns:a="http://schemas.openxmlformats.org/drawingml/2006/main">
+            <a:off x="9810750" y="3857625"/>
+            <a:ext cx="1524000" cy="228600"/>
+          </a:xfrm>
+          <a:prstGeom xmlns:a="http://schemas.openxmlformats.org/drawingml/2006/main" prst="rect">
+            <a:avLst/>
+          </a:prstGeom>
+          <a:noFill xmlns:a="http://schemas.openxmlformats.org/drawingml/2006/main"/>
+          <a:ln xmlns:a="http://schemas.openxmlformats.org/drawingml/2006/main" w="0">
+            <a:noFill/>
+            <a:prstDash val="solid"/>
+          </a:ln>
+        </p:spPr>
+        <p:txBody>
+          <a:bodyPr xmlns:a="http://schemas.openxmlformats.org/drawingml/2006/main" anchor="ctr">
+            <a:normAutofit fontScale="85714"/>
+          </a:bodyPr>
+          <a:lstStyle xmlns:a="http://schemas.openxmlformats.org/drawingml/2006/main"/>
+          <a:p xmlns:a="http://schemas.openxmlformats.org/drawingml/2006/main">
+            <a:pPr algn="ctr">
+              <a:defRPr sz="1050" b="1">
+                <a:solidFill>
+                  <a:srgbClr val="246BFD"/>
+                </a:solidFill>
+                <a:latin typeface="Helvetica Neue"/>
+                <a:ea typeface="Helvetica Neue"/>
+                <a:cs typeface="Helvetica Neue"/>
+              </a:defRPr>
+            </a:pPr>
+            <a:r>
+              <a:rPr sz="1050" b="1">
+                <a:solidFill>
+                  <a:srgbClr val="246BFD"/>
+                </a:solidFill>
+                <a:latin typeface="Helvetica Neue"/>
+                <a:ea typeface="Helvetica Neue"/>
+                <a:cs typeface="Helvetica Neue"/>
+              </a:rPr>
+              <a:t>Ctrl / ⌘ + X</a:t>
+            </a:r>
+          </a:p>
+        </p:txBody>
+      </p:sp>
+      <p:sp>
+        <p:nvSpPr>
+          <p:cNvPr id="38" name="shortcut-cut-description">
+            <a:extLst xmlns:a="http://schemas.openxmlformats.org/drawingml/2006/main">
+              <a:ext uri="{FF2B5EF4-FFF2-40B4-BE49-F238E27FC236}">
+                <a16:creationId xmlns:a16="http://schemas.microsoft.com/office/drawing/2014/main" id="{09500679-70A1-418C-93F2-FAF4FE8FBB05}"/>
+              </a:ext>
+            </a:extLst>
+          </p:cNvPr>
+          <p:cNvSpPr>
+            <a:spLocks xmlns:a="http://schemas.openxmlformats.org/drawingml/2006/main" noGrp="1"/>
+          </p:cNvSpPr>
+          <p:nvPr/>
+        </p:nvSpPr>
+        <p:spPr>
+          <a:xfrm xmlns:a="http://schemas.openxmlformats.org/drawingml/2006/main">
+            <a:off x="8515350" y="4400550"/>
+            <a:ext cx="2914650" cy="381000"/>
+          </a:xfrm>
+          <a:prstGeom xmlns:a="http://schemas.openxmlformats.org/drawingml/2006/main" prst="rect">
+            <a:avLst/>
+          </a:prstGeom>
+          <a:noFill xmlns:a="http://schemas.openxmlformats.org/drawingml/2006/main"/>
+          <a:ln xmlns:a="http://schemas.openxmlformats.org/drawingml/2006/main" w="0">
+            <a:noFill/>
+            <a:prstDash val="solid"/>
+          </a:ln>
+        </p:spPr>
+        <p:txBody>
+          <a:bodyPr xmlns:a="http://schemas.openxmlformats.org/drawingml/2006/main" anchor="t">
+            <a:normAutofit fontScale="100000"/>
+          </a:bodyPr>
+          <a:lstStyle xmlns:a="http://schemas.openxmlformats.org/drawingml/2006/main"/>
+          <a:p xmlns:a="http://schemas.openxmlformats.org/drawingml/2006/main">
+            <a:pPr algn="l">
+              <a:defRPr sz="1575">
+                <a:solidFill>
+                  <a:srgbClr val="5B667A"/>
+                </a:solidFill>
+                <a:latin typeface="Helvetica Neue"/>
+                <a:ea typeface="Helvetica Neue"/>
+                <a:cs typeface="Helvetica Neue"/>
+              </a:defRPr>
+            </a:pPr>
+            <a:r>
+              <a:rPr sz="1575">
+                <a:solidFill>
+                  <a:srgbClr val="5B667A"/>
+                </a:solidFill>
+                <a:latin typeface="Helvetica Neue"/>
+                <a:ea typeface="Helvetica Neue"/>
+                <a:cs typeface="Helvetica Neue"/>
+              </a:rPr>
+              <a:t>選択した内容を移動する</a:t>
             </a:r>
           </a:p>
         </p:txBody>

</xml_diff>